<commit_message>
Add enhanced PPT v3 with Google AI/Antigravity slides and roadmap
</commit_message>
<xml_diff>
--- a/Final_Submission_Prototype_v2.pptx
+++ b/Final_Submission_Prototype_v2.pptx
@@ -269,7 +269,7 @@
       </p:grpSpPr>
       <p:sp>
         <p:nvSpPr>
-          <p:cNvPr id="423879934" name="Google Shape;3;n"/>
+          <p:cNvPr id="1535867746" name="Google Shape;3;n"/>
           <p:cNvSpPr/>
           <p:nvPr>
             <p:ph type="sldImg" idx="2"/>
@@ -318,7 +318,7 @@
       </p:sp>
       <p:sp>
         <p:nvSpPr>
-          <p:cNvPr id="512571459" name="Google Shape;4;n"/>
+          <p:cNvPr id="1572327131" name="Google Shape;4;n"/>
           <p:cNvSpPr txBox="1"/>
           <p:nvPr>
             <p:ph type="body" idx="1"/>
@@ -695,7 +695,7 @@
       </p:grpSpPr>
       <p:sp>
         <p:nvSpPr>
-          <p:cNvPr id="1944429242" name="Google Shape;96;g3c07f7ad1a1_2_45:notes"/>
+          <p:cNvPr id="649395843" name="Google Shape;96;g3c07f7ad1a1_2_45:notes"/>
           <p:cNvSpPr/>
           <p:nvPr>
             <p:ph type="sldImg" idx="2"/>
@@ -744,7 +744,7 @@
       </p:sp>
       <p:sp>
         <p:nvSpPr>
-          <p:cNvPr id="582904258" name="Google Shape;97;g3c07f7ad1a1_2_45:notes"/>
+          <p:cNvPr id="385906303" name="Google Shape;97;g3c07f7ad1a1_2_45:notes"/>
           <p:cNvSpPr txBox="1"/>
           <p:nvPr>
             <p:ph type="body" idx="1"/>
@@ -814,7 +814,7 @@
       </p:grpSpPr>
       <p:sp>
         <p:nvSpPr>
-          <p:cNvPr id="1132962593" name="Google Shape;154;g3c07f7ad1a1_2_102:notes"/>
+          <p:cNvPr id="295445075" name="Google Shape;154;g3c07f7ad1a1_2_102:notes"/>
           <p:cNvSpPr/>
           <p:nvPr>
             <p:ph type="sldImg" idx="2"/>
@@ -863,7 +863,7 @@
       </p:sp>
       <p:sp>
         <p:nvSpPr>
-          <p:cNvPr id="2010294619" name="Google Shape;155;g3c07f7ad1a1_2_102:notes"/>
+          <p:cNvPr id="374170878" name="Google Shape;155;g3c07f7ad1a1_2_102:notes"/>
           <p:cNvSpPr txBox="1"/>
           <p:nvPr>
             <p:ph type="body" idx="1"/>
@@ -933,7 +933,7 @@
       </p:grpSpPr>
       <p:sp>
         <p:nvSpPr>
-          <p:cNvPr id="84076815" name="Google Shape;160;g3c07f7ad1a1_2_109:notes"/>
+          <p:cNvPr id="624725029" name="Google Shape;160;g3c07f7ad1a1_2_109:notes"/>
           <p:cNvSpPr/>
           <p:nvPr>
             <p:ph type="sldImg" idx="2"/>
@@ -982,7 +982,7 @@
       </p:sp>
       <p:sp>
         <p:nvSpPr>
-          <p:cNvPr id="2143981179" name="Google Shape;161;g3c07f7ad1a1_2_109:notes"/>
+          <p:cNvPr id="597966187" name="Google Shape;161;g3c07f7ad1a1_2_109:notes"/>
           <p:cNvSpPr txBox="1"/>
           <p:nvPr>
             <p:ph type="body" idx="1"/>
@@ -1052,7 +1052,7 @@
       </p:grpSpPr>
       <p:sp>
         <p:nvSpPr>
-          <p:cNvPr id="1054590664" name="Google Shape;166;g3c07f7ad1a1_2_116:notes"/>
+          <p:cNvPr id="392478237" name="Google Shape;166;g3c07f7ad1a1_2_116:notes"/>
           <p:cNvSpPr/>
           <p:nvPr>
             <p:ph type="sldImg" idx="2"/>
@@ -1101,7 +1101,7 @@
       </p:sp>
       <p:sp>
         <p:nvSpPr>
-          <p:cNvPr id="1821751395" name="Google Shape;167;g3c07f7ad1a1_2_116:notes"/>
+          <p:cNvPr id="1388564222" name="Google Shape;167;g3c07f7ad1a1_2_116:notes"/>
           <p:cNvSpPr txBox="1"/>
           <p:nvPr>
             <p:ph type="body" idx="1"/>
@@ -1171,7 +1171,7 @@
       </p:grpSpPr>
       <p:sp>
         <p:nvSpPr>
-          <p:cNvPr id="705779643" name="Google Shape;172;g3c07f7ad1a1_2_123:notes"/>
+          <p:cNvPr id="441024336" name="Google Shape;172;g3c07f7ad1a1_2_123:notes"/>
           <p:cNvSpPr/>
           <p:nvPr>
             <p:ph type="sldImg" idx="2"/>
@@ -1220,7 +1220,7 @@
       </p:sp>
       <p:sp>
         <p:nvSpPr>
-          <p:cNvPr id="858385622" name="Google Shape;173;g3c07f7ad1a1_2_123:notes"/>
+          <p:cNvPr id="914569687" name="Google Shape;173;g3c07f7ad1a1_2_123:notes"/>
           <p:cNvSpPr txBox="1"/>
           <p:nvPr>
             <p:ph type="body" idx="1"/>
@@ -1290,7 +1290,7 @@
       </p:grpSpPr>
       <p:sp>
         <p:nvSpPr>
-          <p:cNvPr id="215742747" name="Google Shape;178;g3c07f7ad1a1_2_130:notes"/>
+          <p:cNvPr id="2115062646" name="Google Shape;178;g3c07f7ad1a1_2_130:notes"/>
           <p:cNvSpPr/>
           <p:nvPr>
             <p:ph type="sldImg" idx="2"/>
@@ -1339,7 +1339,7 @@
       </p:sp>
       <p:sp>
         <p:nvSpPr>
-          <p:cNvPr id="976709295" name="Google Shape;179;g3c07f7ad1a1_2_130:notes"/>
+          <p:cNvPr id="750963884" name="Google Shape;179;g3c07f7ad1a1_2_130:notes"/>
           <p:cNvSpPr txBox="1"/>
           <p:nvPr>
             <p:ph type="body" idx="1"/>
@@ -1409,7 +1409,7 @@
       </p:grpSpPr>
       <p:sp>
         <p:nvSpPr>
-          <p:cNvPr id="1560219816" name="Google Shape;183;g3c07f7ad1a1_2_136:notes"/>
+          <p:cNvPr id="1535086495" name="Google Shape;183;g3c07f7ad1a1_2_136:notes"/>
           <p:cNvSpPr/>
           <p:nvPr>
             <p:ph type="sldImg" idx="2"/>
@@ -1458,7 +1458,7 @@
       </p:sp>
       <p:sp>
         <p:nvSpPr>
-          <p:cNvPr id="1147783348" name="Google Shape;184;g3c07f7ad1a1_2_136:notes"/>
+          <p:cNvPr id="907706353" name="Google Shape;184;g3c07f7ad1a1_2_136:notes"/>
           <p:cNvSpPr txBox="1"/>
           <p:nvPr>
             <p:ph type="body" idx="1"/>
@@ -1528,7 +1528,7 @@
       </p:grpSpPr>
       <p:sp>
         <p:nvSpPr>
-          <p:cNvPr id="1400440977" name="Google Shape;104;g3c07f7ad1a1_2_52:notes"/>
+          <p:cNvPr id="436784886" name="Google Shape;104;g3c07f7ad1a1_2_52:notes"/>
           <p:cNvSpPr/>
           <p:nvPr>
             <p:ph type="sldImg" idx="2"/>
@@ -1577,7 +1577,7 @@
       </p:sp>
       <p:sp>
         <p:nvSpPr>
-          <p:cNvPr id="1083316903" name="Google Shape;105;g3c07f7ad1a1_2_52:notes"/>
+          <p:cNvPr id="595839049" name="Google Shape;105;g3c07f7ad1a1_2_52:notes"/>
           <p:cNvSpPr txBox="1"/>
           <p:nvPr>
             <p:ph type="body" idx="1"/>
@@ -1647,7 +1647,7 @@
       </p:grpSpPr>
       <p:sp>
         <p:nvSpPr>
-          <p:cNvPr id="840782571" name="Google Shape;112;g3c07f7ad1a1_2_59:notes"/>
+          <p:cNvPr id="1121657344" name="Google Shape;112;g3c07f7ad1a1_2_59:notes"/>
           <p:cNvSpPr/>
           <p:nvPr>
             <p:ph type="sldImg" idx="2"/>
@@ -1696,7 +1696,7 @@
       </p:sp>
       <p:sp>
         <p:nvSpPr>
-          <p:cNvPr id="1449537796" name="Google Shape;113;g3c07f7ad1a1_2_59:notes"/>
+          <p:cNvPr id="1911304550" name="Google Shape;113;g3c07f7ad1a1_2_59:notes"/>
           <p:cNvSpPr txBox="1"/>
           <p:nvPr>
             <p:ph type="body" idx="1"/>
@@ -1766,7 +1766,7 @@
       </p:grpSpPr>
       <p:sp>
         <p:nvSpPr>
-          <p:cNvPr id="2100714134" name="Google Shape;118;g3c07f7ad1a1_2_64:notes"/>
+          <p:cNvPr id="1055710528" name="Google Shape;118;g3c07f7ad1a1_2_64:notes"/>
           <p:cNvSpPr/>
           <p:nvPr>
             <p:ph type="sldImg" idx="2"/>
@@ -1815,7 +1815,7 @@
       </p:sp>
       <p:sp>
         <p:nvSpPr>
-          <p:cNvPr id="1335291691" name="Google Shape;119;g3c07f7ad1a1_2_64:notes"/>
+          <p:cNvPr id="1498994100" name="Google Shape;119;g3c07f7ad1a1_2_64:notes"/>
           <p:cNvSpPr txBox="1"/>
           <p:nvPr>
             <p:ph type="body" idx="1"/>
@@ -1885,7 +1885,7 @@
       </p:grpSpPr>
       <p:sp>
         <p:nvSpPr>
-          <p:cNvPr id="2134564683" name="Google Shape;124;g3c07f7ad1a1_2_69:notes"/>
+          <p:cNvPr id="1243057168" name="Google Shape;124;g3c07f7ad1a1_2_69:notes"/>
           <p:cNvSpPr/>
           <p:nvPr>
             <p:ph type="sldImg" idx="2"/>
@@ -1934,7 +1934,7 @@
       </p:sp>
       <p:sp>
         <p:nvSpPr>
-          <p:cNvPr id="1139134071" name="Google Shape;125;g3c07f7ad1a1_2_69:notes"/>
+          <p:cNvPr id="1976596134" name="Google Shape;125;g3c07f7ad1a1_2_69:notes"/>
           <p:cNvSpPr txBox="1"/>
           <p:nvPr>
             <p:ph type="body" idx="1"/>
@@ -2004,7 +2004,7 @@
       </p:grpSpPr>
       <p:sp>
         <p:nvSpPr>
-          <p:cNvPr id="446308068" name="Google Shape;130;g3c07f7ad1a1_2_74:notes"/>
+          <p:cNvPr id="574909883" name="Google Shape;130;g3c07f7ad1a1_2_74:notes"/>
           <p:cNvSpPr/>
           <p:nvPr>
             <p:ph type="sldImg" idx="2"/>
@@ -2053,7 +2053,7 @@
       </p:sp>
       <p:sp>
         <p:nvSpPr>
-          <p:cNvPr id="1936354574" name="Google Shape;131;g3c07f7ad1a1_2_74:notes"/>
+          <p:cNvPr id="1242816922" name="Google Shape;131;g3c07f7ad1a1_2_74:notes"/>
           <p:cNvSpPr txBox="1"/>
           <p:nvPr>
             <p:ph type="body" idx="1"/>
@@ -2123,7 +2123,7 @@
       </p:grpSpPr>
       <p:sp>
         <p:nvSpPr>
-          <p:cNvPr id="460907465" name="Google Shape;136;g3c07f7ad1a1_2_81:notes"/>
+          <p:cNvPr id="669997758" name="Google Shape;136;g3c07f7ad1a1_2_81:notes"/>
           <p:cNvSpPr/>
           <p:nvPr>
             <p:ph type="sldImg" idx="2"/>
@@ -2172,7 +2172,7 @@
       </p:sp>
       <p:sp>
         <p:nvSpPr>
-          <p:cNvPr id="864122533" name="Google Shape;137;g3c07f7ad1a1_2_81:notes"/>
+          <p:cNvPr id="1825013507" name="Google Shape;137;g3c07f7ad1a1_2_81:notes"/>
           <p:cNvSpPr txBox="1"/>
           <p:nvPr>
             <p:ph type="body" idx="1"/>
@@ -2242,7 +2242,7 @@
       </p:grpSpPr>
       <p:sp>
         <p:nvSpPr>
-          <p:cNvPr id="948901302" name="Google Shape;142;g3c07f7ad1a1_2_88:notes"/>
+          <p:cNvPr id="1945210608" name="Google Shape;142;g3c07f7ad1a1_2_88:notes"/>
           <p:cNvSpPr/>
           <p:nvPr>
             <p:ph type="sldImg" idx="2"/>
@@ -2291,7 +2291,7 @@
       </p:sp>
       <p:sp>
         <p:nvSpPr>
-          <p:cNvPr id="1047109487" name="Google Shape;143;g3c07f7ad1a1_2_88:notes"/>
+          <p:cNvPr id="1789122169" name="Google Shape;143;g3c07f7ad1a1_2_88:notes"/>
           <p:cNvSpPr txBox="1"/>
           <p:nvPr>
             <p:ph type="body" idx="1"/>
@@ -2361,7 +2361,7 @@
       </p:grpSpPr>
       <p:sp>
         <p:nvSpPr>
-          <p:cNvPr id="417634191" name="Google Shape;148;g3c07f7ad1a1_2_95:notes"/>
+          <p:cNvPr id="1883226229" name="Google Shape;148;g3c07f7ad1a1_2_95:notes"/>
           <p:cNvSpPr/>
           <p:nvPr>
             <p:ph type="sldImg" idx="2"/>
@@ -2410,7 +2410,7 @@
       </p:sp>
       <p:sp>
         <p:nvSpPr>
-          <p:cNvPr id="1048700094" name="Google Shape;149;g3c07f7ad1a1_2_95:notes"/>
+          <p:cNvPr id="1920151023" name="Google Shape;149;g3c07f7ad1a1_2_95:notes"/>
           <p:cNvSpPr txBox="1"/>
           <p:nvPr>
             <p:ph type="body" idx="1"/>
@@ -2480,7 +2480,7 @@
       </p:grpSpPr>
       <p:sp>
         <p:nvSpPr>
-          <p:cNvPr id="2002893953" name="Google Shape;10;p2"/>
+          <p:cNvPr id="935658221" name="Google Shape;10;p2"/>
           <p:cNvSpPr txBox="1"/>
           <p:nvPr>
             <p:ph type="ctrTitle"/>
@@ -2610,7 +2610,7 @@
       </p:sp>
       <p:sp>
         <p:nvSpPr>
-          <p:cNvPr id="1123981066" name="Google Shape;11;p2"/>
+          <p:cNvPr id="495263406" name="Google Shape;11;p2"/>
           <p:cNvSpPr txBox="1"/>
           <p:nvPr>
             <p:ph type="subTitle" idx="1"/>
@@ -2767,7 +2767,7 @@
       </p:sp>
       <p:sp>
         <p:nvSpPr>
-          <p:cNvPr id="1984386087" name="Google Shape;12;p2"/>
+          <p:cNvPr id="1464048817" name="Google Shape;12;p2"/>
           <p:cNvSpPr txBox="1"/>
           <p:nvPr>
             <p:ph type="sldNum" idx="12"/>
@@ -2870,7 +2870,7 @@
       </p:grpSpPr>
       <p:sp>
         <p:nvSpPr>
-          <p:cNvPr id="1451940069" name="Google Shape;45;p11"/>
+          <p:cNvPr id="1018683194" name="Google Shape;45;p11"/>
           <p:cNvSpPr txBox="1"/>
           <p:nvPr>
             <p:ph type="title" hasCustomPrompt="1"/>
@@ -3004,7 +3004,7 @@
       </p:sp>
       <p:sp>
         <p:nvSpPr>
-          <p:cNvPr id="2044864213" name="Google Shape;46;p11"/>
+          <p:cNvPr id="1916691812" name="Google Shape;46;p11"/>
           <p:cNvSpPr txBox="1"/>
           <p:nvPr>
             <p:ph type="body" idx="1"/>
@@ -3134,7 +3134,7 @@
       </p:sp>
       <p:sp>
         <p:nvSpPr>
-          <p:cNvPr id="1692627681" name="Google Shape;47;p11"/>
+          <p:cNvPr id="1332147239" name="Google Shape;47;p11"/>
           <p:cNvSpPr txBox="1"/>
           <p:nvPr>
             <p:ph type="sldNum" idx="12"/>
@@ -3237,7 +3237,7 @@
       </p:grpSpPr>
       <p:sp>
         <p:nvSpPr>
-          <p:cNvPr id="1485260322" name="Google Shape;49;p12"/>
+          <p:cNvPr id="1549865437" name="Google Shape;49;p12"/>
           <p:cNvSpPr txBox="1"/>
           <p:nvPr>
             <p:ph type="sldNum" idx="12"/>
@@ -3340,7 +3340,7 @@
       </p:grpSpPr>
       <p:sp>
         <p:nvSpPr>
-          <p:cNvPr id="1832419503" name="Google Shape;55;p14"/>
+          <p:cNvPr id="147015919" name="Google Shape;55;p14"/>
           <p:cNvSpPr txBox="1"/>
           <p:nvPr>
             <p:ph type="ctrTitle"/>
@@ -3501,7 +3501,7 @@
       </p:sp>
       <p:sp>
         <p:nvSpPr>
-          <p:cNvPr id="945510332" name="Google Shape;56;p14"/>
+          <p:cNvPr id="1165929495" name="Google Shape;56;p14"/>
           <p:cNvSpPr txBox="1"/>
           <p:nvPr>
             <p:ph type="subTitle" idx="1"/>
@@ -3662,7 +3662,7 @@
       </p:sp>
       <p:sp>
         <p:nvSpPr>
-          <p:cNvPr id="2012639586" name="Google Shape;57;p14"/>
+          <p:cNvPr id="866353239" name="Google Shape;57;p14"/>
           <p:cNvSpPr txBox="1"/>
           <p:nvPr>
             <p:ph type="sldNum" idx="12"/>
@@ -3958,7 +3958,7 @@
       </p:grpSpPr>
       <p:sp>
         <p:nvSpPr>
-          <p:cNvPr id="1328517429" name="Google Shape;59;p15"/>
+          <p:cNvPr id="1842616429" name="Google Shape;59;p15"/>
           <p:cNvSpPr txBox="1"/>
           <p:nvPr>
             <p:ph type="title"/>
@@ -4119,7 +4119,7 @@
       </p:sp>
       <p:sp>
         <p:nvSpPr>
-          <p:cNvPr id="733262425" name="Google Shape;60;p15"/>
+          <p:cNvPr id="1896874759" name="Google Shape;60;p15"/>
           <p:cNvSpPr txBox="1"/>
           <p:nvPr>
             <p:ph type="sldNum" idx="12"/>
@@ -4415,7 +4415,7 @@
       </p:grpSpPr>
       <p:sp>
         <p:nvSpPr>
-          <p:cNvPr id="738834889" name="Google Shape;62;p16"/>
+          <p:cNvPr id="600945559" name="Google Shape;62;p16"/>
           <p:cNvSpPr txBox="1"/>
           <p:nvPr>
             <p:ph type="title"/>
@@ -4576,7 +4576,7 @@
       </p:sp>
       <p:sp>
         <p:nvSpPr>
-          <p:cNvPr id="1918439121" name="Google Shape;63;p16"/>
+          <p:cNvPr id="83150730" name="Google Shape;63;p16"/>
           <p:cNvSpPr txBox="1"/>
           <p:nvPr>
             <p:ph type="body" idx="1"/>
@@ -4737,7 +4737,7 @@
       </p:sp>
       <p:sp>
         <p:nvSpPr>
-          <p:cNvPr id="1325035549" name="Google Shape;64;p16"/>
+          <p:cNvPr id="1592766329" name="Google Shape;64;p16"/>
           <p:cNvSpPr txBox="1"/>
           <p:nvPr>
             <p:ph type="sldNum" idx="12"/>
@@ -5033,7 +5033,7 @@
       </p:grpSpPr>
       <p:sp>
         <p:nvSpPr>
-          <p:cNvPr id="551327647" name="Google Shape;66;p17"/>
+          <p:cNvPr id="1977188762" name="Google Shape;66;p17"/>
           <p:cNvSpPr txBox="1"/>
           <p:nvPr>
             <p:ph type="title"/>
@@ -5194,7 +5194,7 @@
       </p:sp>
       <p:sp>
         <p:nvSpPr>
-          <p:cNvPr id="1295143191" name="Google Shape;67;p17"/>
+          <p:cNvPr id="893036226" name="Google Shape;67;p17"/>
           <p:cNvSpPr txBox="1"/>
           <p:nvPr>
             <p:ph type="body" idx="1"/>
@@ -5355,7 +5355,7 @@
       </p:sp>
       <p:sp>
         <p:nvSpPr>
-          <p:cNvPr id="191449502" name="Google Shape;68;p17"/>
+          <p:cNvPr id="2019061229" name="Google Shape;68;p17"/>
           <p:cNvSpPr txBox="1"/>
           <p:nvPr>
             <p:ph type="body" idx="2"/>
@@ -5516,7 +5516,7 @@
       </p:sp>
       <p:sp>
         <p:nvSpPr>
-          <p:cNvPr id="667766152" name="Google Shape;69;p17"/>
+          <p:cNvPr id="978730081" name="Google Shape;69;p17"/>
           <p:cNvSpPr txBox="1"/>
           <p:nvPr>
             <p:ph type="sldNum" idx="12"/>
@@ -5812,7 +5812,7 @@
       </p:grpSpPr>
       <p:sp>
         <p:nvSpPr>
-          <p:cNvPr id="461423560" name="Google Shape;71;p18"/>
+          <p:cNvPr id="1792073345" name="Google Shape;71;p18"/>
           <p:cNvSpPr txBox="1"/>
           <p:nvPr>
             <p:ph type="title"/>
@@ -5973,7 +5973,7 @@
       </p:sp>
       <p:sp>
         <p:nvSpPr>
-          <p:cNvPr id="126378326" name="Google Shape;72;p18"/>
+          <p:cNvPr id="1761984092" name="Google Shape;72;p18"/>
           <p:cNvSpPr txBox="1"/>
           <p:nvPr>
             <p:ph type="sldNum" idx="12"/>
@@ -6269,7 +6269,7 @@
       </p:grpSpPr>
       <p:sp>
         <p:nvSpPr>
-          <p:cNvPr id="1780827318" name="Google Shape;74;p19"/>
+          <p:cNvPr id="1647743253" name="Google Shape;74;p19"/>
           <p:cNvSpPr txBox="1"/>
           <p:nvPr>
             <p:ph type="title"/>
@@ -6430,7 +6430,7 @@
       </p:sp>
       <p:sp>
         <p:nvSpPr>
-          <p:cNvPr id="285898788" name="Google Shape;75;p19"/>
+          <p:cNvPr id="1847716066" name="Google Shape;75;p19"/>
           <p:cNvSpPr txBox="1"/>
           <p:nvPr>
             <p:ph type="body" idx="1"/>
@@ -6591,7 +6591,7 @@
       </p:sp>
       <p:sp>
         <p:nvSpPr>
-          <p:cNvPr id="219921989" name="Google Shape;76;p19"/>
+          <p:cNvPr id="1289349287" name="Google Shape;76;p19"/>
           <p:cNvSpPr txBox="1"/>
           <p:nvPr>
             <p:ph type="sldNum" idx="12"/>
@@ -6887,7 +6887,7 @@
       </p:grpSpPr>
       <p:sp>
         <p:nvSpPr>
-          <p:cNvPr id="673065629" name="Google Shape;78;p20"/>
+          <p:cNvPr id="1894978672" name="Google Shape;78;p20"/>
           <p:cNvSpPr txBox="1"/>
           <p:nvPr>
             <p:ph type="title"/>
@@ -7048,7 +7048,7 @@
       </p:sp>
       <p:sp>
         <p:nvSpPr>
-          <p:cNvPr id="1406440372" name="Google Shape;79;p20"/>
+          <p:cNvPr id="1517052324" name="Google Shape;79;p20"/>
           <p:cNvSpPr txBox="1"/>
           <p:nvPr>
             <p:ph type="sldNum" idx="12"/>
@@ -7344,7 +7344,7 @@
       </p:grpSpPr>
       <p:sp>
         <p:nvSpPr>
-          <p:cNvPr id="1012795931" name="Google Shape;81;p21"/>
+          <p:cNvPr id="764196731" name="Google Shape;81;p21"/>
           <p:cNvSpPr/>
           <p:nvPr/>
         </p:nvSpPr>
@@ -7400,7 +7400,7 @@
       </p:sp>
       <p:sp>
         <p:nvSpPr>
-          <p:cNvPr id="228170493" name="Google Shape;82;p21"/>
+          <p:cNvPr id="1442348731" name="Google Shape;82;p21"/>
           <p:cNvSpPr txBox="1"/>
           <p:nvPr>
             <p:ph type="title"/>
@@ -7561,7 +7561,7 @@
       </p:sp>
       <p:sp>
         <p:nvSpPr>
-          <p:cNvPr id="36066397" name="Google Shape;83;p21"/>
+          <p:cNvPr id="968092760" name="Google Shape;83;p21"/>
           <p:cNvSpPr txBox="1"/>
           <p:nvPr>
             <p:ph type="subTitle" idx="1"/>
@@ -7722,7 +7722,7 @@
       </p:sp>
       <p:sp>
         <p:nvSpPr>
-          <p:cNvPr id="1944897394" name="Google Shape;84;p21"/>
+          <p:cNvPr id="1600246245" name="Google Shape;84;p21"/>
           <p:cNvSpPr txBox="1"/>
           <p:nvPr>
             <p:ph type="body" idx="2"/>
@@ -7883,7 +7883,7 @@
       </p:sp>
       <p:sp>
         <p:nvSpPr>
-          <p:cNvPr id="884583322" name="Google Shape;85;p21"/>
+          <p:cNvPr id="1660137835" name="Google Shape;85;p21"/>
           <p:cNvSpPr txBox="1"/>
           <p:nvPr>
             <p:ph type="sldNum" idx="12"/>
@@ -8179,7 +8179,7 @@
       </p:grpSpPr>
       <p:sp>
         <p:nvSpPr>
-          <p:cNvPr id="1186734052" name="Google Shape;14;p3"/>
+          <p:cNvPr id="1316027655" name="Google Shape;14;p3"/>
           <p:cNvSpPr txBox="1"/>
           <p:nvPr>
             <p:ph type="title"/>
@@ -8309,7 +8309,7 @@
       </p:sp>
       <p:sp>
         <p:nvSpPr>
-          <p:cNvPr id="1348823424" name="Google Shape;15;p3"/>
+          <p:cNvPr id="338734717" name="Google Shape;15;p3"/>
           <p:cNvSpPr txBox="1"/>
           <p:nvPr>
             <p:ph type="sldNum" idx="12"/>
@@ -8412,7 +8412,7 @@
       </p:grpSpPr>
       <p:sp>
         <p:nvSpPr>
-          <p:cNvPr id="1072265891" name="Google Shape;87;p22"/>
+          <p:cNvPr id="732789356" name="Google Shape;87;p22"/>
           <p:cNvSpPr txBox="1"/>
           <p:nvPr>
             <p:ph type="body" idx="1"/>
@@ -8461,7 +8461,7 @@
       </p:sp>
       <p:sp>
         <p:nvSpPr>
-          <p:cNvPr id="1146031123" name="Google Shape;88;p22"/>
+          <p:cNvPr id="1058219869" name="Google Shape;88;p22"/>
           <p:cNvSpPr txBox="1"/>
           <p:nvPr>
             <p:ph type="sldNum" idx="12"/>
@@ -8757,7 +8757,7 @@
       </p:grpSpPr>
       <p:sp>
         <p:nvSpPr>
-          <p:cNvPr id="1484315511" name="Google Shape;90;p23"/>
+          <p:cNvPr id="1400965998" name="Google Shape;90;p23"/>
           <p:cNvSpPr txBox="1"/>
           <p:nvPr>
             <p:ph type="title" hasCustomPrompt="1"/>
@@ -8922,7 +8922,7 @@
       </p:sp>
       <p:sp>
         <p:nvSpPr>
-          <p:cNvPr id="738416532" name="Google Shape;91;p23"/>
+          <p:cNvPr id="461945911" name="Google Shape;91;p23"/>
           <p:cNvSpPr txBox="1"/>
           <p:nvPr>
             <p:ph type="body" idx="1"/>
@@ -9083,7 +9083,7 @@
       </p:sp>
       <p:sp>
         <p:nvSpPr>
-          <p:cNvPr id="564703125" name="Google Shape;92;p23"/>
+          <p:cNvPr id="1003982517" name="Google Shape;92;p23"/>
           <p:cNvSpPr txBox="1"/>
           <p:nvPr>
             <p:ph type="sldNum" idx="12"/>
@@ -9379,7 +9379,7 @@
       </p:grpSpPr>
       <p:sp>
         <p:nvSpPr>
-          <p:cNvPr id="510181758" name="Google Shape;94;p24"/>
+          <p:cNvPr id="917001214" name="Google Shape;94;p24"/>
           <p:cNvSpPr txBox="1"/>
           <p:nvPr>
             <p:ph type="sldNum" idx="12"/>
@@ -9675,7 +9675,7 @@
       </p:grpSpPr>
       <p:sp>
         <p:nvSpPr>
-          <p:cNvPr id="1047237526" name="Google Shape;17;p4"/>
+          <p:cNvPr id="789375808" name="Google Shape;17;p4"/>
           <p:cNvSpPr txBox="1"/>
           <p:nvPr>
             <p:ph type="title"/>
@@ -9805,7 +9805,7 @@
       </p:sp>
       <p:sp>
         <p:nvSpPr>
-          <p:cNvPr id="525637570" name="Google Shape;18;p4"/>
+          <p:cNvPr id="2144296399" name="Google Shape;18;p4"/>
           <p:cNvSpPr txBox="1"/>
           <p:nvPr>
             <p:ph type="body" idx="1"/>
@@ -9935,7 +9935,7 @@
       </p:sp>
       <p:sp>
         <p:nvSpPr>
-          <p:cNvPr id="68309758" name="Google Shape;19;p4"/>
+          <p:cNvPr id="1605365838" name="Google Shape;19;p4"/>
           <p:cNvSpPr txBox="1"/>
           <p:nvPr>
             <p:ph type="sldNum" idx="12"/>
@@ -10038,7 +10038,7 @@
       </p:grpSpPr>
       <p:sp>
         <p:nvSpPr>
-          <p:cNvPr id="1134727601" name="Google Shape;21;p5"/>
+          <p:cNvPr id="1976105889" name="Google Shape;21;p5"/>
           <p:cNvSpPr txBox="1"/>
           <p:nvPr>
             <p:ph type="title"/>
@@ -10168,7 +10168,7 @@
       </p:sp>
       <p:sp>
         <p:nvSpPr>
-          <p:cNvPr id="1539934170" name="Google Shape;22;p5"/>
+          <p:cNvPr id="173552261" name="Google Shape;22;p5"/>
           <p:cNvSpPr txBox="1"/>
           <p:nvPr>
             <p:ph type="body" idx="1"/>
@@ -10298,7 +10298,7 @@
       </p:sp>
       <p:sp>
         <p:nvSpPr>
-          <p:cNvPr id="704255503" name="Google Shape;23;p5"/>
+          <p:cNvPr id="1798076291" name="Google Shape;23;p5"/>
           <p:cNvSpPr txBox="1"/>
           <p:nvPr>
             <p:ph type="body" idx="2"/>
@@ -10428,7 +10428,7 @@
       </p:sp>
       <p:sp>
         <p:nvSpPr>
-          <p:cNvPr id="472904360" name="Google Shape;24;p5"/>
+          <p:cNvPr id="1543252322" name="Google Shape;24;p5"/>
           <p:cNvSpPr txBox="1"/>
           <p:nvPr>
             <p:ph type="sldNum" idx="12"/>
@@ -10531,7 +10531,7 @@
       </p:grpSpPr>
       <p:sp>
         <p:nvSpPr>
-          <p:cNvPr id="287743484" name="Google Shape;26;p6"/>
+          <p:cNvPr id="1639463155" name="Google Shape;26;p6"/>
           <p:cNvSpPr txBox="1"/>
           <p:nvPr>
             <p:ph type="title"/>
@@ -10661,7 +10661,7 @@
       </p:sp>
       <p:sp>
         <p:nvSpPr>
-          <p:cNvPr id="1573845160" name="Google Shape;27;p6"/>
+          <p:cNvPr id="1254163907" name="Google Shape;27;p6"/>
           <p:cNvSpPr txBox="1"/>
           <p:nvPr>
             <p:ph type="sldNum" idx="12"/>
@@ -10764,7 +10764,7 @@
       </p:grpSpPr>
       <p:sp>
         <p:nvSpPr>
-          <p:cNvPr id="839720150" name="Google Shape;29;p7"/>
+          <p:cNvPr id="587112969" name="Google Shape;29;p7"/>
           <p:cNvSpPr txBox="1"/>
           <p:nvPr>
             <p:ph type="title"/>
@@ -10894,7 +10894,7 @@
       </p:sp>
       <p:sp>
         <p:nvSpPr>
-          <p:cNvPr id="889852170" name="Google Shape;30;p7"/>
+          <p:cNvPr id="515161865" name="Google Shape;30;p7"/>
           <p:cNvSpPr txBox="1"/>
           <p:nvPr>
             <p:ph type="body" idx="1"/>
@@ -11024,7 +11024,7 @@
       </p:sp>
       <p:sp>
         <p:nvSpPr>
-          <p:cNvPr id="1840019928" name="Google Shape;31;p7"/>
+          <p:cNvPr id="346147397" name="Google Shape;31;p7"/>
           <p:cNvSpPr txBox="1"/>
           <p:nvPr>
             <p:ph type="sldNum" idx="12"/>
@@ -11127,7 +11127,7 @@
       </p:grpSpPr>
       <p:sp>
         <p:nvSpPr>
-          <p:cNvPr id="187267663" name="Google Shape;33;p8"/>
+          <p:cNvPr id="811269486" name="Google Shape;33;p8"/>
           <p:cNvSpPr txBox="1"/>
           <p:nvPr>
             <p:ph type="title"/>
@@ -11257,7 +11257,7 @@
       </p:sp>
       <p:sp>
         <p:nvSpPr>
-          <p:cNvPr id="661871276" name="Google Shape;34;p8"/>
+          <p:cNvPr id="1300424648" name="Google Shape;34;p8"/>
           <p:cNvSpPr txBox="1"/>
           <p:nvPr>
             <p:ph type="sldNum" idx="12"/>
@@ -11360,7 +11360,7 @@
       </p:grpSpPr>
       <p:sp>
         <p:nvSpPr>
-          <p:cNvPr id="166123026" name="Google Shape;36;p9"/>
+          <p:cNvPr id="1086974845" name="Google Shape;36;p9"/>
           <p:cNvSpPr/>
           <p:nvPr/>
         </p:nvSpPr>
@@ -11401,7 +11401,7 @@
       </p:sp>
       <p:sp>
         <p:nvSpPr>
-          <p:cNvPr id="1378942162" name="Google Shape;37;p9"/>
+          <p:cNvPr id="866557428" name="Google Shape;37;p9"/>
           <p:cNvSpPr txBox="1"/>
           <p:nvPr>
             <p:ph type="title"/>
@@ -11531,7 +11531,7 @@
       </p:sp>
       <p:sp>
         <p:nvSpPr>
-          <p:cNvPr id="969926076" name="Google Shape;38;p9"/>
+          <p:cNvPr id="1090967910" name="Google Shape;38;p9"/>
           <p:cNvSpPr txBox="1"/>
           <p:nvPr>
             <p:ph type="subTitle" idx="1"/>
@@ -11688,7 +11688,7 @@
       </p:sp>
       <p:sp>
         <p:nvSpPr>
-          <p:cNvPr id="1181807595" name="Google Shape;39;p9"/>
+          <p:cNvPr id="1629982503" name="Google Shape;39;p9"/>
           <p:cNvSpPr txBox="1"/>
           <p:nvPr>
             <p:ph type="body" idx="2"/>
@@ -11818,7 +11818,7 @@
       </p:sp>
       <p:sp>
         <p:nvSpPr>
-          <p:cNvPr id="1995174135" name="Google Shape;40;p9"/>
+          <p:cNvPr id="377607589" name="Google Shape;40;p9"/>
           <p:cNvSpPr txBox="1"/>
           <p:nvPr>
             <p:ph type="sldNum" idx="12"/>
@@ -11921,7 +11921,7 @@
       </p:grpSpPr>
       <p:sp>
         <p:nvSpPr>
-          <p:cNvPr id="672126359" name="Google Shape;42;p10"/>
+          <p:cNvPr id="24728978" name="Google Shape;42;p10"/>
           <p:cNvSpPr txBox="1"/>
           <p:nvPr>
             <p:ph type="body" idx="1"/>
@@ -11966,7 +11966,7 @@
       </p:sp>
       <p:sp>
         <p:nvSpPr>
-          <p:cNvPr id="456140054" name="Google Shape;43;p10"/>
+          <p:cNvPr id="1287051307" name="Google Shape;43;p10"/>
           <p:cNvSpPr txBox="1"/>
           <p:nvPr>
             <p:ph type="sldNum" idx="12"/>
@@ -12076,7 +12076,7 @@
       </p:grpSpPr>
       <p:sp>
         <p:nvSpPr>
-          <p:cNvPr id="1588277376" name="Google Shape;6;p1"/>
+          <p:cNvPr id="2000838525" name="Google Shape;6;p1"/>
           <p:cNvSpPr txBox="1"/>
           <p:nvPr>
             <p:ph type="title"/>
@@ -12273,7 +12273,7 @@
       </p:sp>
       <p:sp>
         <p:nvSpPr>
-          <p:cNvPr id="22900813" name="Google Shape;7;p1"/>
+          <p:cNvPr id="735848276" name="Google Shape;7;p1"/>
           <p:cNvSpPr txBox="1"/>
           <p:nvPr>
             <p:ph type="body" idx="1"/>
@@ -12497,7 +12497,7 @@
       </p:sp>
       <p:sp>
         <p:nvSpPr>
-          <p:cNvPr id="198763807" name="Google Shape;8;p1"/>
+          <p:cNvPr id="739950370" name="Google Shape;8;p1"/>
           <p:cNvSpPr txBox="1"/>
           <p:nvPr>
             <p:ph type="sldNum" idx="12"/>
@@ -13321,7 +13321,7 @@
       </p:grpSpPr>
       <p:sp>
         <p:nvSpPr>
-          <p:cNvPr id="403887265" name="Google Shape;51;p13"/>
+          <p:cNvPr id="1324166129" name="Google Shape;51;p13"/>
           <p:cNvSpPr txBox="1"/>
           <p:nvPr>
             <p:ph type="title"/>
@@ -13581,7 +13581,7 @@
       </p:sp>
       <p:sp>
         <p:nvSpPr>
-          <p:cNvPr id="831227781" name="Google Shape;52;p13"/>
+          <p:cNvPr id="980235557" name="Google Shape;52;p13"/>
           <p:cNvSpPr txBox="1"/>
           <p:nvPr>
             <p:ph type="body" idx="1"/>
@@ -13841,7 +13841,7 @@
       </p:sp>
       <p:sp>
         <p:nvSpPr>
-          <p:cNvPr id="1345901362" name="Google Shape;53;p13"/>
+          <p:cNvPr id="1484772586" name="Google Shape;53;p13"/>
           <p:cNvSpPr txBox="1"/>
           <p:nvPr>
             <p:ph type="sldNum" idx="12"/>
@@ -14811,7 +14811,7 @@
       </p:grpSpPr>
       <p:sp>
         <p:nvSpPr>
-          <p:cNvPr id="1179638180" name="Google Shape;99;p25"/>
+          <p:cNvPr id="1889396168" name="Google Shape;99;p25"/>
           <p:cNvSpPr txBox="1"/>
           <p:nvPr/>
         </p:nvSpPr>
@@ -14876,7 +14876,7 @@
       </p:sp>
       <p:sp>
         <p:nvSpPr>
-          <p:cNvPr id="448557627" name="Google Shape;100;p25"/>
+          <p:cNvPr id="1544611977" name="Google Shape;100;p25"/>
           <p:cNvSpPr txBox="1"/>
           <p:nvPr/>
         </p:nvSpPr>
@@ -15169,7 +15169,7 @@
       </p:sp>
       <p:pic>
         <p:nvPicPr>
-          <p:cNvPr id="1171328980" name="Google Shape;101;p25" title="frameeeee.png"/>
+          <p:cNvPr id="1531324491" name="Google Shape;101;p25" title="frameeeee.png"/>
           <p:cNvPicPr/>
           <p:nvPr/>
         </p:nvPicPr>
@@ -15195,7 +15195,7 @@
       </p:pic>
       <p:sp>
         <p:nvSpPr>
-          <p:cNvPr id="364618856" name="Google Shape;102;p25"/>
+          <p:cNvPr id="1592121634" name="Google Shape;102;p25"/>
           <p:cNvSpPr txBox="1"/>
           <p:nvPr/>
         </p:nvSpPr>
@@ -15296,7 +15296,7 @@
       </p:grpSpPr>
       <p:sp>
         <p:nvSpPr>
-          <p:cNvPr id="569895451" name="Google Shape;157;p34"/>
+          <p:cNvPr id="1030776927" name="Google Shape;157;p34"/>
           <p:cNvSpPr txBox="1"/>
           <p:nvPr/>
         </p:nvSpPr>
@@ -15314,7 +15314,7 @@
           </a:ln>
         </p:spPr>
         <p:txBody>
-          <a:bodyPr spcFirstLastPara="1" wrap="square" lIns="91424" tIns="91424" rIns="91424" bIns="91424" anchor="t" anchorCtr="0">
+          <a:bodyPr spcFirstLastPara="1" wrap="square" lIns="91423" tIns="91423" rIns="91423" bIns="91423" anchor="t" anchorCtr="0">
             <a:noAutofit/>
           </a:bodyPr>
           <a:lstStyle/>
@@ -15628,7 +15628,7 @@
       </p:sp>
       <p:pic>
         <p:nvPicPr>
-          <p:cNvPr id="317525208" name="Google Shape;158;p34" title="frameeeee.png"/>
+          <p:cNvPr id="1201078721" name="Google Shape;158;p34" title="frameeeee.png"/>
           <p:cNvPicPr/>
           <p:nvPr/>
         </p:nvPicPr>
@@ -15687,7 +15687,7 @@
       </p:grpSpPr>
       <p:sp>
         <p:nvSpPr>
-          <p:cNvPr id="607972780" name="Google Shape;163;p35"/>
+          <p:cNvPr id="1966532307" name="Google Shape;163;p35"/>
           <p:cNvSpPr txBox="1"/>
           <p:nvPr/>
         </p:nvSpPr>
@@ -15752,7 +15752,7 @@
       </p:sp>
       <p:pic>
         <p:nvPicPr>
-          <p:cNvPr id="459100274" name="Google Shape;164;p35" title="frameeeee.png"/>
+          <p:cNvPr id="1424128116" name="Google Shape;164;p35" title="frameeeee.png"/>
           <p:cNvPicPr/>
           <p:nvPr/>
         </p:nvPicPr>
@@ -15778,7 +15778,7 @@
       </p:pic>
       <p:pic>
         <p:nvPicPr>
-          <p:cNvPr id="227868770" name="Picture 164" descr="click_feedback_1776967314381.png"/>
+          <p:cNvPr id="952711018" name="Picture 164" descr="click_feedback_1776967314381.png"/>
           <p:cNvPicPr>
             <a:picLocks noChangeAspect="1"/>
           </p:cNvPicPr>
@@ -15800,7 +15800,7 @@
       </p:pic>
       <p:pic>
         <p:nvPicPr>
-          <p:cNvPr id="2006525601" name=""/>
+          <p:cNvPr id="2136357756" name=""/>
           <p:cNvPicPr>
             <a:picLocks noChangeAspect="1"/>
           </p:cNvPicPr>
@@ -15855,7 +15855,7 @@
       </p:grpSpPr>
       <p:sp>
         <p:nvSpPr>
-          <p:cNvPr id="79710888" name="Google Shape;169;p36"/>
+          <p:cNvPr id="277800930" name="Google Shape;169;p36"/>
           <p:cNvSpPr txBox="1"/>
           <p:nvPr/>
         </p:nvSpPr>
@@ -15873,7 +15873,7 @@
           </a:ln>
         </p:spPr>
         <p:txBody>
-          <a:bodyPr spcFirstLastPara="1" wrap="square" lIns="91424" tIns="91424" rIns="91424" bIns="91424" anchor="t" anchorCtr="0">
+          <a:bodyPr spcFirstLastPara="1" wrap="square" lIns="91423" tIns="91423" rIns="91423" bIns="91423" anchor="t" anchorCtr="0">
             <a:noAutofit/>
           </a:bodyPr>
           <a:lstStyle/>
@@ -16111,7 +16111,7 @@
       </p:sp>
       <p:pic>
         <p:nvPicPr>
-          <p:cNvPr id="1848122680" name="Google Shape;170;p36" title="frameeeee.png"/>
+          <p:cNvPr id="1998865241" name="Google Shape;170;p36" title="frameeeee.png"/>
           <p:cNvPicPr/>
           <p:nvPr/>
         </p:nvPicPr>
@@ -16170,7 +16170,7 @@
       </p:grpSpPr>
       <p:sp>
         <p:nvSpPr>
-          <p:cNvPr id="1795728756" name="Google Shape;175;p37"/>
+          <p:cNvPr id="599136760" name="Google Shape;175;p37"/>
           <p:cNvSpPr txBox="1"/>
           <p:nvPr/>
         </p:nvSpPr>
@@ -16289,36 +16289,8 @@
               </a:rPr>
               <a:t>GitHub Public Repository</a:t>
             </a:r>
-            <a:endParaRPr sz="1800" b="0" i="0" u="none" strike="noStrike" cap="none">
-              <a:solidFill>
-                <a:srgbClr val="000000"/>
-              </a:solidFill>
-              <a:latin typeface="Google Sans"/>
-              <a:ea typeface="Google Sans"/>
-              <a:cs typeface="Google Sans"/>
-            </a:endParaRPr>
-          </a:p>
-          <a:p>
-            <a:pPr marL="457200" marR="0" lvl="0" indent="-342900" algn="l" rtl="0">
-              <a:lnSpc>
-                <a:spcPct val="100000"/>
-              </a:lnSpc>
-              <a:spcBef>
-                <a:spcPts val="0"/>
-              </a:spcBef>
-              <a:spcAft>
-                <a:spcPts val="0"/>
-              </a:spcAft>
-              <a:buClr>
-                <a:srgbClr val="000000"/>
-              </a:buClr>
-              <a:buSzPts val="1800"/>
-              <a:buFont typeface="Google Sans"/>
-              <a:buAutoNum type="arabicPeriod"/>
-              <a:defRPr/>
-            </a:pPr>
             <a:r>
-              <a:rPr lang="en-GB" sz="1800" b="0" i="0" u="none" strike="noStrike" cap="none">
+              <a:rPr lang="en-IN" sz="1800" b="0" i="0" u="none" strike="noStrike" cap="none">
                 <a:solidFill>
                   <a:srgbClr val="000000"/>
                 </a:solidFill>
@@ -16326,7 +16298,16 @@
                 <a:ea typeface="Google Sans"/>
                 <a:cs typeface="Google Sans"/>
               </a:rPr>
-              <a:t>Demo Video Link (3 Minutes)</a:t>
+              <a:t>    -  </a:t>
+            </a:r>
+            <a:r>
+              <a:rPr u="sng">
+                <a:solidFill>
+                  <a:schemeClr val="hlink"/>
+                </a:solidFill>
+                <a:hlinkClick r:id="rId3" tooltip=""/>
+              </a:rPr>
+              <a:t>https://github.com/nawangdorjay/google-ai-solution-challenge--smart-resource-allocation</a:t>
             </a:r>
             <a:endParaRPr sz="1800" b="0" i="0" u="none" strike="noStrike" cap="none">
               <a:solidFill>
@@ -16365,7 +16346,18 @@
                 <a:ea typeface="Google Sans"/>
                 <a:cs typeface="Google Sans"/>
               </a:rPr>
-              <a:t>MVP Link</a:t>
+              <a:t>Demo Video Link (3 Minutes)</a:t>
+            </a:r>
+            <a:r>
+              <a:rPr lang="en-IN" sz="1800" b="0" i="0" u="none" strike="noStrike" cap="none">
+                <a:solidFill>
+                  <a:srgbClr val="000000"/>
+                </a:solidFill>
+                <a:latin typeface="Google Sans"/>
+                <a:ea typeface="Google Sans"/>
+                <a:cs typeface="Google Sans"/>
+              </a:rPr>
+              <a:t>:</a:t>
             </a:r>
             <a:endParaRPr sz="1800" b="0" i="0" u="none" strike="noStrike" cap="none">
               <a:solidFill>
@@ -16387,6 +16379,67 @@
               <a:spcAft>
                 <a:spcPts val="0"/>
               </a:spcAft>
+              <a:buClr>
+                <a:srgbClr val="000000"/>
+              </a:buClr>
+              <a:buSzPts val="1800"/>
+              <a:buFont typeface="Google Sans"/>
+              <a:buAutoNum type="arabicPeriod"/>
+              <a:defRPr/>
+            </a:pPr>
+            <a:r>
+              <a:rPr lang="en-GB" sz="1800" b="0" i="0" u="none" strike="noStrike" cap="none">
+                <a:solidFill>
+                  <a:srgbClr val="000000"/>
+                </a:solidFill>
+                <a:latin typeface="Google Sans"/>
+                <a:ea typeface="Google Sans"/>
+                <a:cs typeface="Google Sans"/>
+              </a:rPr>
+              <a:t>MVP Link</a:t>
+            </a:r>
+            <a:r>
+              <a:rPr lang="en-IN" sz="1800" b="0" i="0" u="none" strike="noStrike" cap="none">
+                <a:solidFill>
+                  <a:srgbClr val="000000"/>
+                </a:solidFill>
+                <a:latin typeface="Google Sans"/>
+                <a:ea typeface="Google Sans"/>
+                <a:cs typeface="Google Sans"/>
+              </a:rPr>
+              <a:t> : -  </a:t>
+            </a:r>
+            <a:r>
+              <a:rPr lang="en-IN" sz="1800" b="0" i="0" u="none" strike="noStrike" cap="none" spc="0">
+                <a:solidFill>
+                  <a:srgbClr val="000000"/>
+                </a:solidFill>
+                <a:latin typeface="Google Sans"/>
+                <a:ea typeface="Google Sans"/>
+                <a:cs typeface="Google Sans"/>
+              </a:rPr>
+              <a:t>https://google-ai-solution-challenge-smart.onrender.com</a:t>
+            </a:r>
+            <a:endParaRPr sz="1800" b="0" i="0" u="none" strike="noStrike" cap="none">
+              <a:solidFill>
+                <a:srgbClr val="000000"/>
+              </a:solidFill>
+              <a:latin typeface="Google Sans"/>
+              <a:ea typeface="Google Sans"/>
+              <a:cs typeface="Google Sans"/>
+            </a:endParaRPr>
+          </a:p>
+          <a:p>
+            <a:pPr marL="457200" marR="0" lvl="0" indent="-342900" algn="l" rtl="0">
+              <a:lnSpc>
+                <a:spcPct val="100000"/>
+              </a:lnSpc>
+              <a:spcBef>
+                <a:spcPts val="0"/>
+              </a:spcBef>
+              <a:spcAft>
+                <a:spcPts val="0"/>
+              </a:spcAft>
               <a:buSzPts val="1800"/>
               <a:buFont typeface="Google Sans"/>
               <a:buAutoNum type="arabicPeriod"/>
@@ -16399,6 +16452,25 @@
                 <a:cs typeface="Google Sans"/>
               </a:rPr>
               <a:t>Working Prototype Link</a:t>
+            </a:r>
+            <a:r>
+              <a:rPr lang="en-IN" sz="1800">
+                <a:latin typeface="Google Sans"/>
+                <a:ea typeface="Google Sans"/>
+                <a:cs typeface="Google Sans"/>
+              </a:rPr>
+              <a:t>: -  </a:t>
+            </a:r>
+            <a:r>
+              <a:rPr lang="en-IN" sz="1800" b="0" i="0" u="none" strike="noStrike" cap="none" spc="0">
+                <a:solidFill>
+                  <a:srgbClr val="000000"/>
+                </a:solidFill>
+                <a:latin typeface="Google Sans"/>
+                <a:ea typeface="Google Sans"/>
+                <a:cs typeface="Google Sans"/>
+              </a:rPr>
+              <a:t>https://google-ai-solution-challenge-smart.onrender.com</a:t>
             </a:r>
             <a:endParaRPr sz="1800">
               <a:latin typeface="Google Sans"/>
@@ -16410,12 +16482,12 @@
       </p:sp>
       <p:pic>
         <p:nvPicPr>
-          <p:cNvPr id="1644730714" name="Google Shape;176;p37" title="frameeeee.png"/>
+          <p:cNvPr id="280046574" name="Google Shape;176;p37" title="frameeeee.png"/>
           <p:cNvPicPr/>
           <p:nvPr/>
         </p:nvPicPr>
         <p:blipFill rotWithShape="1">
-          <a:blip r:embed="rId3">
+          <a:blip r:embed="rId4">
             <a:alphaModFix/>
           </a:blip>
           <a:stretch/>
@@ -16469,7 +16541,7 @@
       </p:grpSpPr>
       <p:pic>
         <p:nvPicPr>
-          <p:cNvPr id="1658356816" name="Google Shape;181;p38" title="frameeeee.png"/>
+          <p:cNvPr id="1607007521" name="Google Shape;181;p38" title="frameeeee.png"/>
           <p:cNvPicPr/>
           <p:nvPr/>
         </p:nvPicPr>
@@ -16528,7 +16600,7 @@
       </p:grpSpPr>
       <p:pic>
         <p:nvPicPr>
-          <p:cNvPr id="1963917648" name="Google Shape;186;p39" title="38d89ed3-9ded-48f6-b368-c62c46c50b68 1 [Vectorized].png"/>
+          <p:cNvPr id="788838946" name="Google Shape;186;p39" title="38d89ed3-9ded-48f6-b368-c62c46c50b68 1 [Vectorized].png"/>
           <p:cNvPicPr/>
           <p:nvPr/>
         </p:nvPicPr>
@@ -16588,7 +16660,7 @@
       </p:grpSpPr>
       <p:sp>
         <p:nvSpPr>
-          <p:cNvPr id="1975526811" name="Google Shape;107;p26"/>
+          <p:cNvPr id="586561195" name="Google Shape;107;p26"/>
           <p:cNvSpPr txBox="1"/>
           <p:nvPr>
             <p:ph type="subTitle" idx="1"/>
@@ -16633,7 +16705,7 @@
       </p:sp>
       <p:pic>
         <p:nvPicPr>
-          <p:cNvPr id="1345929662" name="Google Shape;108;p26"/>
+          <p:cNvPr id="946527356" name="Google Shape;108;p26"/>
           <p:cNvPicPr/>
           <p:nvPr/>
         </p:nvPicPr>
@@ -16660,7 +16732,7 @@
       </p:pic>
       <p:sp>
         <p:nvSpPr>
-          <p:cNvPr id="68394821" name="Google Shape;109;p26"/>
+          <p:cNvPr id="441375310" name="Google Shape;109;p26"/>
           <p:cNvSpPr txBox="1"/>
           <p:nvPr/>
         </p:nvSpPr>
@@ -16761,7 +16833,7 @@
       </p:sp>
       <p:pic>
         <p:nvPicPr>
-          <p:cNvPr id="1226621533" name="Google Shape;110;p26" title="Frame 96.png"/>
+          <p:cNvPr id="778479121" name="Google Shape;110;p26" title="Frame 96.png"/>
           <p:cNvPicPr/>
           <p:nvPr/>
         </p:nvPicPr>
@@ -16821,7 +16893,7 @@
       </p:grpSpPr>
       <p:sp>
         <p:nvSpPr>
-          <p:cNvPr id="245534561" name="Google Shape;115;p27"/>
+          <p:cNvPr id="1299409177" name="Google Shape;115;p27"/>
           <p:cNvSpPr txBox="1"/>
           <p:nvPr/>
         </p:nvSpPr>
@@ -16886,7 +16958,7 @@
       </p:sp>
       <p:pic>
         <p:nvPicPr>
-          <p:cNvPr id="1846884430" name="Google Shape;116;p27" title="frameeeee.png"/>
+          <p:cNvPr id="878038939" name="Google Shape;116;p27" title="frameeeee.png"/>
           <p:cNvPicPr/>
           <p:nvPr/>
         </p:nvPicPr>
@@ -16912,7 +16984,7 @@
       </p:pic>
       <p:sp>
         <p:nvSpPr>
-          <p:cNvPr id="1422974771" name="TextBox 116"/>
+          <p:cNvPr id="358766363" name="TextBox 116"/>
           <p:cNvSpPr txBox="1"/>
           <p:nvPr/>
         </p:nvSpPr>
@@ -16998,14 +17070,14 @@
       </p:grpSpPr>
       <p:sp>
         <p:nvSpPr>
-          <p:cNvPr id="1437252952" name="Google Shape;121;p28"/>
+          <p:cNvPr id="511691424" name="Google Shape;121;p28"/>
           <p:cNvSpPr txBox="1"/>
           <p:nvPr/>
         </p:nvSpPr>
         <p:spPr bwMode="auto">
-          <a:xfrm>
-            <a:off x="183250" y="818550"/>
-            <a:ext cx="8784300" cy="1419300"/>
+          <a:xfrm flipH="0" flipV="0">
+            <a:off x="183249" y="818550"/>
+            <a:ext cx="8784299" cy="532444"/>
           </a:xfrm>
           <a:prstGeom prst="rect">
             <a:avLst/>
@@ -17016,7 +17088,7 @@
           </a:ln>
         </p:spPr>
         <p:txBody>
-          <a:bodyPr spcFirstLastPara="1" wrap="square" lIns="91425" tIns="91425" rIns="91425" bIns="91425" anchor="t" anchorCtr="0">
+          <a:bodyPr spcFirstLastPara="1" wrap="square" lIns="91424" tIns="91424" rIns="91424" bIns="91424" anchor="t" anchorCtr="0">
             <a:noAutofit/>
           </a:bodyPr>
           <a:lstStyle/>
@@ -17039,17 +17111,6 @@
               <a:buNone/>
               <a:defRPr/>
             </a:pPr>
-            <a:r>
-              <a:rPr lang="en-GB" sz="1800" b="0" i="0" u="none" strike="noStrike" cap="none">
-                <a:solidFill>
-                  <a:srgbClr val="000000"/>
-                </a:solidFill>
-                <a:latin typeface="Google Sans"/>
-                <a:ea typeface="Google Sans"/>
-                <a:cs typeface="Google Sans"/>
-              </a:rPr>
-              <a:t>Opportunities</a:t>
-            </a:r>
             <a:endParaRPr sz="1800" b="0" i="0" u="none" strike="noStrike" cap="none">
               <a:solidFill>
                 <a:srgbClr val="000000"/>
@@ -17060,7 +17121,7 @@
             </a:endParaRPr>
           </a:p>
           <a:p>
-            <a:pPr marL="914400" marR="0" lvl="1" indent="-342900" algn="l" rtl="0">
+            <a:pPr lvl="1" algn="l" rtl="0">
               <a:lnSpc>
                 <a:spcPct val="114999"/>
               </a:lnSpc>
@@ -17070,103 +17131,8 @@
               <a:spcAft>
                 <a:spcPts val="0"/>
               </a:spcAft>
-              <a:buClr>
-                <a:srgbClr val="000000"/>
-              </a:buClr>
-              <a:buSzPts val="1800"/>
-              <a:buFont typeface="Google Sans"/>
-              <a:buAutoNum type="alphaLcPeriod"/>
               <a:defRPr/>
             </a:pPr>
-            <a:r>
-              <a:rPr lang="en-GB" sz="1800" b="0" i="0" u="none" strike="noStrike" cap="none">
-                <a:solidFill>
-                  <a:srgbClr val="000000"/>
-                </a:solidFill>
-                <a:latin typeface="Google Sans"/>
-                <a:ea typeface="Google Sans"/>
-                <a:cs typeface="Google Sans"/>
-              </a:rPr>
-              <a:t>How different is it from any of the other existing ideas?</a:t>
-            </a:r>
-            <a:endParaRPr sz="1800" b="0" i="0" u="none" strike="noStrike" cap="none">
-              <a:solidFill>
-                <a:srgbClr val="000000"/>
-              </a:solidFill>
-              <a:latin typeface="Google Sans"/>
-              <a:ea typeface="Google Sans"/>
-              <a:cs typeface="Google Sans"/>
-            </a:endParaRPr>
-          </a:p>
-          <a:p>
-            <a:pPr marL="914400" marR="0" lvl="1" indent="-342900" algn="l" rtl="0">
-              <a:lnSpc>
-                <a:spcPct val="114999"/>
-              </a:lnSpc>
-              <a:spcBef>
-                <a:spcPts val="0"/>
-              </a:spcBef>
-              <a:spcAft>
-                <a:spcPts val="0"/>
-              </a:spcAft>
-              <a:buClr>
-                <a:srgbClr val="000000"/>
-              </a:buClr>
-              <a:buSzPts val="1800"/>
-              <a:buFont typeface="Google Sans"/>
-              <a:buAutoNum type="alphaLcPeriod"/>
-              <a:defRPr/>
-            </a:pPr>
-            <a:r>
-              <a:rPr lang="en-GB" sz="1800" b="0" i="0" u="none" strike="noStrike" cap="none">
-                <a:solidFill>
-                  <a:srgbClr val="000000"/>
-                </a:solidFill>
-                <a:latin typeface="Google Sans"/>
-                <a:ea typeface="Google Sans"/>
-                <a:cs typeface="Google Sans"/>
-              </a:rPr>
-              <a:t>How will it be able to solve the problem?</a:t>
-            </a:r>
-            <a:endParaRPr sz="1800" b="0" i="0" u="none" strike="noStrike" cap="none">
-              <a:solidFill>
-                <a:srgbClr val="000000"/>
-              </a:solidFill>
-              <a:latin typeface="Google Sans"/>
-              <a:ea typeface="Google Sans"/>
-              <a:cs typeface="Google Sans"/>
-            </a:endParaRPr>
-          </a:p>
-          <a:p>
-            <a:pPr marL="914400" marR="0" lvl="1" indent="-342900" algn="l" rtl="0">
-              <a:lnSpc>
-                <a:spcPct val="114999"/>
-              </a:lnSpc>
-              <a:spcBef>
-                <a:spcPts val="0"/>
-              </a:spcBef>
-              <a:spcAft>
-                <a:spcPts val="0"/>
-              </a:spcAft>
-              <a:buClr>
-                <a:srgbClr val="000000"/>
-              </a:buClr>
-              <a:buSzPts val="1800"/>
-              <a:buFont typeface="Google Sans"/>
-              <a:buAutoNum type="alphaLcPeriod"/>
-              <a:defRPr/>
-            </a:pPr>
-            <a:r>
-              <a:rPr lang="en-GB" sz="1800" b="0" i="0" u="none" strike="noStrike" cap="none">
-                <a:solidFill>
-                  <a:srgbClr val="000000"/>
-                </a:solidFill>
-                <a:latin typeface="Google Sans"/>
-                <a:ea typeface="Google Sans"/>
-                <a:cs typeface="Google Sans"/>
-              </a:rPr>
-              <a:t>USP of the proposed solution</a:t>
-            </a:r>
             <a:endParaRPr sz="1800">
               <a:latin typeface="Google Sans"/>
               <a:ea typeface="Google Sans"/>
@@ -17205,7 +17171,7 @@
       </p:sp>
       <p:pic>
         <p:nvPicPr>
-          <p:cNvPr id="1262141953" name="Google Shape;122;p28" title="frameeeee.png"/>
+          <p:cNvPr id="1637955560" name="Google Shape;122;p28" title="frameeeee.png"/>
           <p:cNvPicPr/>
           <p:nvPr/>
         </p:nvPicPr>
@@ -17231,14 +17197,14 @@
       </p:pic>
       <p:sp>
         <p:nvSpPr>
-          <p:cNvPr id="1477692416" name="TextBox 122"/>
+          <p:cNvPr id="121702245" name="TextBox 122"/>
           <p:cNvSpPr txBox="1"/>
           <p:nvPr/>
         </p:nvSpPr>
         <p:spPr bwMode="auto">
           <a:xfrm rot="0" flipH="0" flipV="0">
-            <a:off x="457199" y="2089668"/>
-            <a:ext cx="8185770" cy="3017880"/>
+            <a:off x="183249" y="818550"/>
+            <a:ext cx="8694065" cy="3261719"/>
           </a:xfrm>
           <a:prstGeom prst="rect">
             <a:avLst/>
@@ -17258,6 +17224,12 @@
               <a:rPr/>
               <a:t>Opportunities &amp; Market Differentiation</a:t>
             </a:r>
+            <a:endParaRPr/>
+          </a:p>
+          <a:p>
+            <a:pPr>
+              <a:defRPr sz="1600"/>
+            </a:pPr>
             <a:br>
               <a:rPr/>
             </a:br>
@@ -17328,7 +17300,7 @@
       </p:grpSpPr>
       <p:sp>
         <p:nvSpPr>
-          <p:cNvPr id="989392733" name="Google Shape;127;p29"/>
+          <p:cNvPr id="1655775964" name="Google Shape;127;p29"/>
           <p:cNvSpPr txBox="1"/>
           <p:nvPr/>
         </p:nvSpPr>
@@ -17393,7 +17365,7 @@
       </p:sp>
       <p:pic>
         <p:nvPicPr>
-          <p:cNvPr id="1595769779" name="Google Shape;128;p29" title="frameeeee.png"/>
+          <p:cNvPr id="25423199" name="Google Shape;128;p29" title="frameeeee.png"/>
           <p:cNvPicPr/>
           <p:nvPr/>
         </p:nvPicPr>
@@ -17419,7 +17391,7 @@
       </p:pic>
       <p:sp>
         <p:nvSpPr>
-          <p:cNvPr id="1886031669" name="TextBox 128"/>
+          <p:cNvPr id="807726188" name="TextBox 128"/>
           <p:cNvSpPr txBox="1"/>
           <p:nvPr/>
         </p:nvSpPr>
@@ -17533,7 +17505,7 @@
       </p:grpSpPr>
       <p:sp>
         <p:nvSpPr>
-          <p:cNvPr id="765031267" name="Google Shape;133;p30"/>
+          <p:cNvPr id="630361324" name="Google Shape;133;p30"/>
           <p:cNvSpPr txBox="1"/>
           <p:nvPr/>
         </p:nvSpPr>
@@ -17598,7 +17570,7 @@
       </p:sp>
       <p:pic>
         <p:nvPicPr>
-          <p:cNvPr id="285495554" name="Google Shape;134;p30" title="frameeeee.png"/>
+          <p:cNvPr id="1381308906" name="Google Shape;134;p30" title="frameeeee.png"/>
           <p:cNvPicPr/>
           <p:nvPr/>
         </p:nvPicPr>
@@ -17624,7 +17596,7 @@
       </p:pic>
       <p:sp>
         <p:nvSpPr>
-          <p:cNvPr id="847724611" name="Rounded Rectangle 134"/>
+          <p:cNvPr id="510892419" name="Rounded Rectangle 134"/>
           <p:cNvSpPr/>
           <p:nvPr/>
         </p:nvSpPr>
@@ -17692,7 +17664,7 @@
       </p:sp>
       <p:sp>
         <p:nvSpPr>
-          <p:cNvPr id="996471700" name="Right Arrow 135"/>
+          <p:cNvPr id="1144393034" name="Right Arrow 135"/>
           <p:cNvSpPr/>
           <p:nvPr/>
         </p:nvSpPr>
@@ -17735,7 +17707,7 @@
       </p:sp>
       <p:sp>
         <p:nvSpPr>
-          <p:cNvPr id="737833925" name="Rounded Rectangle 136"/>
+          <p:cNvPr id="1913318871" name="Rounded Rectangle 136"/>
           <p:cNvSpPr/>
           <p:nvPr/>
         </p:nvSpPr>
@@ -17803,7 +17775,7 @@
       </p:sp>
       <p:sp>
         <p:nvSpPr>
-          <p:cNvPr id="1682890178" name="Right Arrow 137"/>
+          <p:cNvPr id="1463257467" name="Right Arrow 137"/>
           <p:cNvSpPr/>
           <p:nvPr/>
         </p:nvSpPr>
@@ -17846,7 +17818,7 @@
       </p:sp>
       <p:sp>
         <p:nvSpPr>
-          <p:cNvPr id="1377809383" name="Rounded Rectangle 138"/>
+          <p:cNvPr id="1418622859" name="Rounded Rectangle 138"/>
           <p:cNvSpPr/>
           <p:nvPr/>
         </p:nvSpPr>
@@ -17914,7 +17886,7 @@
       </p:sp>
       <p:sp>
         <p:nvSpPr>
-          <p:cNvPr id="945259379" name="Right Arrow 139"/>
+          <p:cNvPr id="112864769" name="Right Arrow 139"/>
           <p:cNvSpPr/>
           <p:nvPr/>
         </p:nvSpPr>
@@ -17957,7 +17929,7 @@
       </p:sp>
       <p:sp>
         <p:nvSpPr>
-          <p:cNvPr id="567355472" name="Rounded Rectangle 140"/>
+          <p:cNvPr id="374485479" name="Rounded Rectangle 140"/>
           <p:cNvSpPr/>
           <p:nvPr/>
         </p:nvSpPr>
@@ -18025,7 +17997,7 @@
       </p:sp>
       <p:sp>
         <p:nvSpPr>
-          <p:cNvPr id="1156965256" name="Down Arrow 141"/>
+          <p:cNvPr id="1399759550" name="Down Arrow 141"/>
           <p:cNvSpPr/>
           <p:nvPr/>
         </p:nvSpPr>
@@ -18068,7 +18040,7 @@
       </p:sp>
       <p:sp>
         <p:nvSpPr>
-          <p:cNvPr id="1836941032" name="Rounded Rectangle 142"/>
+          <p:cNvPr id="1620643925" name="Rounded Rectangle 142"/>
           <p:cNvSpPr/>
           <p:nvPr/>
         </p:nvSpPr>
@@ -18136,7 +18108,7 @@
       </p:sp>
       <p:sp>
         <p:nvSpPr>
-          <p:cNvPr id="317505067" name="TextBox 143"/>
+          <p:cNvPr id="47967136" name="TextBox 143"/>
           <p:cNvSpPr txBox="1"/>
           <p:nvPr/>
         </p:nvSpPr>
@@ -18202,7 +18174,7 @@
       </p:grpSpPr>
       <p:sp>
         <p:nvSpPr>
-          <p:cNvPr id="343026502" name="Google Shape;139;p31"/>
+          <p:cNvPr id="107074308" name="Google Shape;139;p31"/>
           <p:cNvSpPr txBox="1"/>
           <p:nvPr/>
         </p:nvSpPr>
@@ -18267,7 +18239,7 @@
       </p:sp>
       <p:pic>
         <p:nvPicPr>
-          <p:cNvPr id="1406228359" name="Google Shape;140;p31" title="frameeeee.png"/>
+          <p:cNvPr id="358140877" name="Google Shape;140;p31" title="frameeeee.png"/>
           <p:cNvPicPr/>
           <p:nvPr/>
         </p:nvPicPr>
@@ -18326,7 +18298,7 @@
       </p:grpSpPr>
       <p:sp>
         <p:nvSpPr>
-          <p:cNvPr id="282562374" name="Google Shape;145;p32"/>
+          <p:cNvPr id="60387347" name="Google Shape;145;p32"/>
           <p:cNvSpPr txBox="1"/>
           <p:nvPr/>
         </p:nvSpPr>
@@ -18391,7 +18363,7 @@
       </p:sp>
       <p:pic>
         <p:nvPicPr>
-          <p:cNvPr id="1019406104" name="Google Shape;146;p32" title="frameeeee.png"/>
+          <p:cNvPr id="536263624" name="Google Shape;146;p32" title="frameeeee.png"/>
           <p:cNvPicPr/>
           <p:nvPr/>
         </p:nvPicPr>
@@ -18417,7 +18389,7 @@
       </p:pic>
       <p:sp>
         <p:nvSpPr>
-          <p:cNvPr id="1341142406" name="Rounded Rectangle 146"/>
+          <p:cNvPr id="1650630180" name="Rounded Rectangle 146"/>
           <p:cNvSpPr/>
           <p:nvPr/>
         </p:nvSpPr>
@@ -18480,7 +18452,7 @@
       </p:sp>
       <p:sp>
         <p:nvSpPr>
-          <p:cNvPr id="1766763966" name="Right Arrow 147"/>
+          <p:cNvPr id="1106076902" name="Right Arrow 147"/>
           <p:cNvSpPr/>
           <p:nvPr/>
         </p:nvSpPr>
@@ -18523,7 +18495,7 @@
       </p:sp>
       <p:sp>
         <p:nvSpPr>
-          <p:cNvPr id="2132868075" name="Rounded Rectangle 148"/>
+          <p:cNvPr id="1221450938" name="Rounded Rectangle 148"/>
           <p:cNvSpPr/>
           <p:nvPr/>
         </p:nvSpPr>
@@ -18586,7 +18558,7 @@
       </p:sp>
       <p:sp>
         <p:nvSpPr>
-          <p:cNvPr id="858777567" name="Down Arrow 149"/>
+          <p:cNvPr id="364871449" name="Down Arrow 149"/>
           <p:cNvSpPr/>
           <p:nvPr/>
         </p:nvSpPr>
@@ -18629,7 +18601,7 @@
       </p:sp>
       <p:sp>
         <p:nvSpPr>
-          <p:cNvPr id="1983070558" name="Rounded Rectangle 150"/>
+          <p:cNvPr id="652303653" name="Rounded Rectangle 150"/>
           <p:cNvSpPr/>
           <p:nvPr/>
         </p:nvSpPr>
@@ -18676,10 +18648,6 @@
               <a:rPr/>
               <a:t>SQLite Database</a:t>
             </a:r>
-            <a:r>
-              <a:rPr lang="en-IN"/>
-              <a:t>, Excel</a:t>
-            </a:r>
             <a:endParaRPr/>
           </a:p>
           <a:p>
@@ -18696,7 +18664,7 @@
       </p:sp>
       <p:sp>
         <p:nvSpPr>
-          <p:cNvPr id="1366907584" name="Right Arrow 151"/>
+          <p:cNvPr id="2091548316" name="Right Arrow 151"/>
           <p:cNvSpPr/>
           <p:nvPr/>
         </p:nvSpPr>
@@ -18739,7 +18707,7 @@
       </p:sp>
       <p:sp>
         <p:nvSpPr>
-          <p:cNvPr id="1219337912" name="Rounded Rectangle 152"/>
+          <p:cNvPr id="196825681" name="Rounded Rectangle 152"/>
           <p:cNvSpPr/>
           <p:nvPr/>
         </p:nvSpPr>
@@ -18792,7 +18760,7 @@
       </p:sp>
       <p:sp>
         <p:nvSpPr>
-          <p:cNvPr id="1741549054" name="Rounded Rectangle 153"/>
+          <p:cNvPr id="1702524592" name="Rounded Rectangle 153"/>
           <p:cNvSpPr/>
           <p:nvPr/>
         </p:nvSpPr>
@@ -18855,7 +18823,7 @@
       </p:sp>
       <p:sp>
         <p:nvSpPr>
-          <p:cNvPr id="1635892492" name="Rounded Rectangle 154"/>
+          <p:cNvPr id="1723463010" name="Rounded Rectangle 154"/>
           <p:cNvSpPr/>
           <p:nvPr/>
         </p:nvSpPr>
@@ -18951,7 +18919,7 @@
       </p:grpSpPr>
       <p:sp>
         <p:nvSpPr>
-          <p:cNvPr id="1358210670" name="Google Shape;151;p33"/>
+          <p:cNvPr id="125143383" name="Google Shape;151;p33"/>
           <p:cNvSpPr txBox="1"/>
           <p:nvPr/>
         </p:nvSpPr>
@@ -19016,7 +18984,7 @@
       </p:sp>
       <p:pic>
         <p:nvPicPr>
-          <p:cNvPr id="329999062" name="Google Shape;152;p33" title="frameeeee.png"/>
+          <p:cNvPr id="926515479" name="Google Shape;152;p33" title="frameeeee.png"/>
           <p:cNvPicPr/>
           <p:nvPr/>
         </p:nvPicPr>
@@ -19042,14 +19010,14 @@
       </p:pic>
       <p:sp>
         <p:nvSpPr>
-          <p:cNvPr id="1893450999" name="TextBox 152"/>
+          <p:cNvPr id="207037405" name="TextBox 152"/>
           <p:cNvSpPr txBox="1"/>
           <p:nvPr/>
         </p:nvSpPr>
         <p:spPr bwMode="auto">
           <a:xfrm>
             <a:off x="457200" y="1371600"/>
-            <a:ext cx="8236799" cy="3017880"/>
+            <a:ext cx="8236798" cy="3017880"/>
           </a:xfrm>
           <a:prstGeom prst="rect">
             <a:avLst/>

</xml_diff>